<commit_message>
Scaffold Expo TypeScript app; restyle deck and web demo to #5CA3FF brand
Co-Authored-By: Claude Fable 5 <noreply@anthropic.com>
</commit_message>
<xml_diff>
--- a/pitch/DigitalTwin-Pitch-Deck.pptx
+++ b/pitch/DigitalTwin-Pitch-Deck.pptx
@@ -3094,7 +3094,7 @@
     <p:bg>
       <p:bgPr>
         <a:solidFill>
-          <a:srgbClr val="3A5D84"/>
+          <a:srgbClr val="5CA3FF"/>
         </a:solidFill>
         <a:effectLst/>
       </p:bgPr>
@@ -3152,7 +3152,7 @@
             <a:r>
               <a:rPr sz="2600" b="0" i="0">
                 <a:solidFill>
-                  <a:srgbClr val="BFD4E8"/>
+                  <a:srgbClr val="ECF4FF"/>
                 </a:solidFill>
                 <a:latin typeface="Avenir Next"/>
               </a:rPr>
@@ -3184,7 +3184,7 @@
             <a:r>
               <a:rPr sz="1400" b="0" i="0">
                 <a:solidFill>
-                  <a:srgbClr val="9FB8D2"/>
+                  <a:srgbClr val="ECF4FF"/>
                 </a:solidFill>
                 <a:latin typeface="Avenir Next"/>
               </a:rPr>
@@ -3207,7 +3207,7 @@
     <p:bg>
       <p:bgPr>
         <a:solidFill>
-          <a:srgbClr val="F4F1EC"/>
+          <a:srgbClr val="FFFFFF"/>
         </a:solidFill>
         <a:effectLst/>
       </p:bgPr>
@@ -3249,7 +3249,7 @@
             <a:r>
               <a:rPr sz="1500" b="1" i="0">
                 <a:solidFill>
-                  <a:srgbClr val="4F7CAC"/>
+                  <a:srgbClr val="2F6FBF"/>
                 </a:solidFill>
                 <a:latin typeface="Avenir Next"/>
               </a:rPr>
@@ -3265,7 +3265,7 @@
             <a:r>
               <a:rPr sz="3800" b="1" i="0">
                 <a:solidFill>
-                  <a:srgbClr val="2B2B33"/>
+                  <a:srgbClr val="1E293B"/>
                 </a:solidFill>
                 <a:latin typeface="Avenir Next"/>
               </a:rPr>
@@ -3289,7 +3289,7 @@
             <a:avLst/>
           </a:prstGeom>
           <a:solidFill>
-            <a:srgbClr val="4F7CAC"/>
+            <a:srgbClr val="5CA3FF"/>
           </a:solidFill>
           <a:ln>
             <a:noFill/>
@@ -3332,7 +3332,7 @@
             <a:avLst/>
           </a:prstGeom>
           <a:solidFill>
-            <a:srgbClr val="FFFFFF"/>
+            <a:srgbClr val="ECF4FF"/>
           </a:solidFill>
           <a:ln>
             <a:noFill/>
@@ -3364,7 +3364,7 @@
             <a:r>
               <a:rPr sz="1900" b="1" i="0">
                 <a:solidFill>
-                  <a:srgbClr val="2B2B33"/>
+                  <a:srgbClr val="1E293B"/>
                 </a:solidFill>
                 <a:latin typeface="Avenir Next"/>
               </a:rPr>
@@ -3380,7 +3380,7 @@
             <a:r>
               <a:rPr sz="1300" b="1" i="0">
                 <a:solidFill>
-                  <a:srgbClr val="4F7CAC"/>
+                  <a:srgbClr val="5CA3FF"/>
                 </a:solidFill>
                 <a:latin typeface="Avenir Next"/>
               </a:rPr>
@@ -3404,7 +3404,7 @@
             <a:avLst/>
           </a:prstGeom>
           <a:solidFill>
-            <a:srgbClr val="FFFFFF"/>
+            <a:srgbClr val="ECF4FF"/>
           </a:solidFill>
           <a:ln>
             <a:noFill/>
@@ -3436,7 +3436,7 @@
             <a:r>
               <a:rPr sz="1900" b="1" i="0">
                 <a:solidFill>
-                  <a:srgbClr val="2B2B33"/>
+                  <a:srgbClr val="1E293B"/>
                 </a:solidFill>
                 <a:latin typeface="Avenir Next"/>
               </a:rPr>
@@ -3476,7 +3476,7 @@
             <a:avLst/>
           </a:prstGeom>
           <a:solidFill>
-            <a:srgbClr val="FFFFFF"/>
+            <a:srgbClr val="ECF4FF"/>
           </a:solidFill>
           <a:ln>
             <a:noFill/>
@@ -3508,7 +3508,7 @@
             <a:r>
               <a:rPr sz="1900" b="1" i="0">
                 <a:solidFill>
-                  <a:srgbClr val="2B2B33"/>
+                  <a:srgbClr val="1E293B"/>
                 </a:solidFill>
                 <a:latin typeface="Avenir Next"/>
               </a:rPr>
@@ -3524,7 +3524,7 @@
             <a:r>
               <a:rPr sz="1300" b="1" i="0">
                 <a:solidFill>
-                  <a:srgbClr val="3A5D84"/>
+                  <a:srgbClr val="2F6FBF"/>
                 </a:solidFill>
                 <a:latin typeface="Avenir Next"/>
               </a:rPr>
@@ -3548,7 +3548,7 @@
             <a:avLst/>
           </a:prstGeom>
           <a:solidFill>
-            <a:srgbClr val="FFFFFF"/>
+            <a:srgbClr val="ECF4FF"/>
           </a:solidFill>
           <a:ln>
             <a:noFill/>
@@ -3580,7 +3580,7 @@
             <a:r>
               <a:rPr sz="1900" b="1" i="0">
                 <a:solidFill>
-                  <a:srgbClr val="2B2B33"/>
+                  <a:srgbClr val="1E293B"/>
                 </a:solidFill>
                 <a:latin typeface="Avenir Next"/>
               </a:rPr>
@@ -3620,7 +3620,7 @@
             <a:avLst/>
           </a:prstGeom>
           <a:solidFill>
-            <a:srgbClr val="FFFFFF"/>
+            <a:srgbClr val="ECF4FF"/>
           </a:solidFill>
           <a:ln>
             <a:noFill/>
@@ -3652,7 +3652,7 @@
             <a:r>
               <a:rPr sz="1900" b="1" i="0">
                 <a:solidFill>
-                  <a:srgbClr val="2B2B33"/>
+                  <a:srgbClr val="1E293B"/>
                 </a:solidFill>
                 <a:latin typeface="Avenir Next"/>
               </a:rPr>
@@ -3668,7 +3668,7 @@
             <a:r>
               <a:rPr sz="1300" b="1" i="0">
                 <a:solidFill>
-                  <a:srgbClr val="6B6B76"/>
+                  <a:srgbClr val="5E6B7E"/>
                 </a:solidFill>
                 <a:latin typeface="Avenir Next"/>
               </a:rPr>
@@ -3691,7 +3691,7 @@
     <p:bg>
       <p:bgPr>
         <a:solidFill>
-          <a:srgbClr val="3A5D84"/>
+          <a:srgbClr val="5CA3FF"/>
         </a:solidFill>
         <a:effectLst/>
       </p:bgPr>
@@ -3733,7 +3733,7 @@
             <a:r>
               <a:rPr sz="3400" b="0" i="0">
                 <a:solidFill>
-                  <a:srgbClr val="BFD4E8"/>
+                  <a:srgbClr val="ECF4FF"/>
                 </a:solidFill>
                 <a:latin typeface="Avenir Next"/>
               </a:rPr>
@@ -3781,7 +3781,7 @@
             <a:r>
               <a:rPr sz="1800" b="0" i="0">
                 <a:solidFill>
-                  <a:srgbClr val="9FB8D2"/>
+                  <a:srgbClr val="ECF4FF"/>
                 </a:solidFill>
                 <a:latin typeface="Avenir Next"/>
               </a:rPr>
@@ -3804,7 +3804,7 @@
     <p:bg>
       <p:bgPr>
         <a:solidFill>
-          <a:srgbClr val="F4F1EC"/>
+          <a:srgbClr val="FFFFFF"/>
         </a:solidFill>
         <a:effectLst/>
       </p:bgPr>
@@ -3846,7 +3846,7 @@
             <a:r>
               <a:rPr sz="1500" b="1" i="0">
                 <a:solidFill>
-                  <a:srgbClr val="4F7CAC"/>
+                  <a:srgbClr val="2F6FBF"/>
                 </a:solidFill>
                 <a:latin typeface="Avenir Next"/>
               </a:rPr>
@@ -3862,7 +3862,7 @@
             <a:r>
               <a:rPr sz="3800" b="1" i="0">
                 <a:solidFill>
-                  <a:srgbClr val="2B2B33"/>
+                  <a:srgbClr val="1E293B"/>
                 </a:solidFill>
                 <a:latin typeface="Avenir Next"/>
               </a:rPr>
@@ -3886,7 +3886,7 @@
             <a:avLst/>
           </a:prstGeom>
           <a:solidFill>
-            <a:srgbClr val="4F7CAC"/>
+            <a:srgbClr val="5CA3FF"/>
           </a:solidFill>
           <a:ln>
             <a:noFill/>
@@ -3944,7 +3944,7 @@
             <a:r>
               <a:rPr sz="2100" b="0" i="0">
                 <a:solidFill>
-                  <a:srgbClr val="2B2B33"/>
+                  <a:srgbClr val="1E293B"/>
                 </a:solidFill>
                 <a:latin typeface="Avenir Next"/>
               </a:rPr>
@@ -3960,7 +3960,7 @@
             <a:r>
               <a:rPr sz="2100" b="0" i="0">
                 <a:solidFill>
-                  <a:srgbClr val="2B2B33"/>
+                  <a:srgbClr val="1E293B"/>
                 </a:solidFill>
                 <a:latin typeface="Avenir Next"/>
               </a:rPr>
@@ -3976,7 +3976,7 @@
             <a:r>
               <a:rPr sz="2100" b="0" i="0">
                 <a:solidFill>
-                  <a:srgbClr val="6B6B76"/>
+                  <a:srgbClr val="5E6B7E"/>
                 </a:solidFill>
                 <a:latin typeface="Avenir Next"/>
               </a:rPr>
@@ -4000,7 +4000,7 @@
             <a:avLst/>
           </a:prstGeom>
           <a:solidFill>
-            <a:srgbClr val="FFFFFF"/>
+            <a:srgbClr val="ECF4FF"/>
           </a:solidFill>
           <a:ln>
             <a:noFill/>
@@ -4032,7 +4032,7 @@
             <a:r>
               <a:rPr sz="4000" b="1" i="0">
                 <a:solidFill>
-                  <a:srgbClr val="4F7CAC"/>
+                  <a:srgbClr val="2F6FBF"/>
                 </a:solidFill>
                 <a:latin typeface="Avenir Next"/>
               </a:rPr>
@@ -4048,7 +4048,7 @@
             <a:r>
               <a:rPr sz="1400" b="0" i="0">
                 <a:solidFill>
-                  <a:srgbClr val="6B6B76"/>
+                  <a:srgbClr val="5E6B7E"/>
                 </a:solidFill>
                 <a:latin typeface="Avenir Next"/>
               </a:rPr>
@@ -4072,7 +4072,7 @@
             <a:avLst/>
           </a:prstGeom>
           <a:solidFill>
-            <a:srgbClr val="FFFFFF"/>
+            <a:srgbClr val="ECF4FF"/>
           </a:solidFill>
           <a:ln>
             <a:noFill/>
@@ -4120,7 +4120,7 @@
             <a:r>
               <a:rPr sz="1400" b="0" i="0">
                 <a:solidFill>
-                  <a:srgbClr val="6B6B76"/>
+                  <a:srgbClr val="5E6B7E"/>
                 </a:solidFill>
                 <a:latin typeface="Avenir Next"/>
               </a:rPr>
@@ -4143,7 +4143,7 @@
     <p:bg>
       <p:bgPr>
         <a:solidFill>
-          <a:srgbClr val="F4F1EC"/>
+          <a:srgbClr val="FFFFFF"/>
         </a:solidFill>
         <a:effectLst/>
       </p:bgPr>
@@ -4185,7 +4185,7 @@
             <a:r>
               <a:rPr sz="1500" b="1" i="0">
                 <a:solidFill>
-                  <a:srgbClr val="4F7CAC"/>
+                  <a:srgbClr val="2F6FBF"/>
                 </a:solidFill>
                 <a:latin typeface="Avenir Next"/>
               </a:rPr>
@@ -4201,7 +4201,7 @@
             <a:r>
               <a:rPr sz="3800" b="1" i="0">
                 <a:solidFill>
-                  <a:srgbClr val="2B2B33"/>
+                  <a:srgbClr val="1E293B"/>
                 </a:solidFill>
                 <a:latin typeface="Avenir Next"/>
               </a:rPr>
@@ -4225,7 +4225,7 @@
             <a:avLst/>
           </a:prstGeom>
           <a:solidFill>
-            <a:srgbClr val="4F7CAC"/>
+            <a:srgbClr val="5CA3FF"/>
           </a:solidFill>
           <a:ln>
             <a:noFill/>
@@ -4268,7 +4268,7 @@
             <a:avLst/>
           </a:prstGeom>
           <a:solidFill>
-            <a:srgbClr val="FFFFFF"/>
+            <a:srgbClr val="ECF4FF"/>
           </a:solidFill>
           <a:ln>
             <a:noFill/>
@@ -4300,7 +4300,7 @@
             <a:r>
               <a:rPr sz="1400" b="1" i="0">
                 <a:solidFill>
-                  <a:srgbClr val="4F7CAC"/>
+                  <a:srgbClr val="2F6FBF"/>
                 </a:solidFill>
                 <a:latin typeface="Avenir Next"/>
               </a:rPr>
@@ -4316,7 +4316,7 @@
             <a:r>
               <a:rPr sz="2200" b="1" i="0">
                 <a:solidFill>
-                  <a:srgbClr val="2B2B33"/>
+                  <a:srgbClr val="1E293B"/>
                 </a:solidFill>
                 <a:latin typeface="Avenir Next"/>
               </a:rPr>
@@ -4332,7 +4332,7 @@
             <a:r>
               <a:rPr sz="1700" b="0" i="1">
                 <a:solidFill>
-                  <a:srgbClr val="6B6B76"/>
+                  <a:srgbClr val="5E6B7E"/>
                 </a:solidFill>
                 <a:latin typeface="Avenir Next"/>
               </a:rPr>
@@ -4348,7 +4348,7 @@
             <a:r>
               <a:rPr sz="1700" b="0" i="0">
                 <a:solidFill>
-                  <a:srgbClr val="6B6B76"/>
+                  <a:srgbClr val="5E6B7E"/>
                 </a:solidFill>
                 <a:latin typeface="Avenir Next"/>
               </a:rPr>
@@ -4372,7 +4372,7 @@
             <a:avLst/>
           </a:prstGeom>
           <a:solidFill>
-            <a:srgbClr val="FFFFFF"/>
+            <a:srgbClr val="ECF4FF"/>
           </a:solidFill>
           <a:ln>
             <a:noFill/>
@@ -4420,7 +4420,7 @@
             <a:r>
               <a:rPr sz="2200" b="1" i="0">
                 <a:solidFill>
-                  <a:srgbClr val="2B2B33"/>
+                  <a:srgbClr val="1E293B"/>
                 </a:solidFill>
                 <a:latin typeface="Avenir Next"/>
               </a:rPr>
@@ -4468,7 +4468,7 @@
             <a:r>
               <a:rPr sz="1700" b="0" i="0">
                 <a:solidFill>
-                  <a:srgbClr val="6B6B76"/>
+                  <a:srgbClr val="5E6B7E"/>
                 </a:solidFill>
                 <a:latin typeface="Avenir Next"/>
               </a:rPr>
@@ -4491,7 +4491,7 @@
     <p:bg>
       <p:bgPr>
         <a:solidFill>
-          <a:srgbClr val="F4F1EC"/>
+          <a:srgbClr val="FFFFFF"/>
         </a:solidFill>
         <a:effectLst/>
       </p:bgPr>
@@ -4533,7 +4533,7 @@
             <a:r>
               <a:rPr sz="1500" b="1" i="0">
                 <a:solidFill>
-                  <a:srgbClr val="4F7CAC"/>
+                  <a:srgbClr val="2F6FBF"/>
                 </a:solidFill>
                 <a:latin typeface="Avenir Next"/>
               </a:rPr>
@@ -4549,7 +4549,7 @@
             <a:r>
               <a:rPr sz="3800" b="1" i="0">
                 <a:solidFill>
-                  <a:srgbClr val="2B2B33"/>
+                  <a:srgbClr val="1E293B"/>
                 </a:solidFill>
                 <a:latin typeface="Avenir Next"/>
               </a:rPr>
@@ -4573,7 +4573,7 @@
             <a:avLst/>
           </a:prstGeom>
           <a:solidFill>
-            <a:srgbClr val="4F7CAC"/>
+            <a:srgbClr val="5CA3FF"/>
           </a:solidFill>
           <a:ln>
             <a:noFill/>
@@ -4631,7 +4631,7 @@
             <a:r>
               <a:rPr sz="2100" b="1" i="0">
                 <a:solidFill>
-                  <a:srgbClr val="2B2B33"/>
+                  <a:srgbClr val="1E293B"/>
                 </a:solidFill>
                 <a:latin typeface="Avenir Next"/>
               </a:rPr>
@@ -4647,7 +4647,7 @@
             <a:r>
               <a:rPr sz="1800" b="0" i="0">
                 <a:solidFill>
-                  <a:srgbClr val="6B6B76"/>
+                  <a:srgbClr val="5E6B7E"/>
                 </a:solidFill>
                 <a:latin typeface="Avenir Next"/>
               </a:rPr>
@@ -4663,7 +4663,7 @@
             <a:r>
               <a:rPr sz="2100" b="1" i="0">
                 <a:solidFill>
-                  <a:srgbClr val="2B2B33"/>
+                  <a:srgbClr val="1E293B"/>
                 </a:solidFill>
                 <a:latin typeface="Avenir Next"/>
               </a:rPr>
@@ -4679,7 +4679,7 @@
             <a:r>
               <a:rPr sz="1800" b="0" i="0">
                 <a:solidFill>
-                  <a:srgbClr val="6B6B76"/>
+                  <a:srgbClr val="5E6B7E"/>
                 </a:solidFill>
                 <a:latin typeface="Avenir Next"/>
               </a:rPr>
@@ -4695,7 +4695,7 @@
             <a:r>
               <a:rPr sz="2100" b="1" i="0">
                 <a:solidFill>
-                  <a:srgbClr val="2B2B33"/>
+                  <a:srgbClr val="1E293B"/>
                 </a:solidFill>
                 <a:latin typeface="Avenir Next"/>
               </a:rPr>
@@ -4711,7 +4711,7 @@
             <a:r>
               <a:rPr sz="1800" b="0" i="0">
                 <a:solidFill>
-                  <a:srgbClr val="6B6B76"/>
+                  <a:srgbClr val="5E6B7E"/>
                 </a:solidFill>
                 <a:latin typeface="Avenir Next"/>
               </a:rPr>
@@ -4727,7 +4727,7 @@
             <a:r>
               <a:rPr sz="2100" b="1" i="0">
                 <a:solidFill>
-                  <a:srgbClr val="2B2B33"/>
+                  <a:srgbClr val="1E293B"/>
                 </a:solidFill>
                 <a:latin typeface="Avenir Next"/>
               </a:rPr>
@@ -4743,7 +4743,7 @@
             <a:r>
               <a:rPr sz="1800" b="0" i="0">
                 <a:solidFill>
-                  <a:srgbClr val="6B6B76"/>
+                  <a:srgbClr val="5E6B7E"/>
                 </a:solidFill>
                 <a:latin typeface="Avenir Next"/>
               </a:rPr>
@@ -4766,7 +4766,7 @@
     <p:bg>
       <p:bgPr>
         <a:solidFill>
-          <a:srgbClr val="F4F1EC"/>
+          <a:srgbClr val="FFFFFF"/>
         </a:solidFill>
         <a:effectLst/>
       </p:bgPr>
@@ -4808,7 +4808,7 @@
             <a:r>
               <a:rPr sz="1500" b="1" i="0">
                 <a:solidFill>
-                  <a:srgbClr val="4F7CAC"/>
+                  <a:srgbClr val="2F6FBF"/>
                 </a:solidFill>
                 <a:latin typeface="Avenir Next"/>
               </a:rPr>
@@ -4824,7 +4824,7 @@
             <a:r>
               <a:rPr sz="3800" b="1" i="0">
                 <a:solidFill>
-                  <a:srgbClr val="2B2B33"/>
+                  <a:srgbClr val="1E293B"/>
                 </a:solidFill>
                 <a:latin typeface="Avenir Next"/>
               </a:rPr>
@@ -4848,7 +4848,7 @@
             <a:avLst/>
           </a:prstGeom>
           <a:solidFill>
-            <a:srgbClr val="4F7CAC"/>
+            <a:srgbClr val="5CA3FF"/>
           </a:solidFill>
           <a:ln>
             <a:noFill/>
@@ -4906,7 +4906,7 @@
             <a:r>
               <a:rPr sz="2100" b="1" i="0">
                 <a:solidFill>
-                  <a:srgbClr val="2B2B33"/>
+                  <a:srgbClr val="1E293B"/>
                 </a:solidFill>
                 <a:latin typeface="Avenir Next"/>
               </a:rPr>
@@ -4922,7 +4922,7 @@
             <a:r>
               <a:rPr sz="1800" b="0" i="0">
                 <a:solidFill>
-                  <a:srgbClr val="6B6B76"/>
+                  <a:srgbClr val="5E6B7E"/>
                 </a:solidFill>
                 <a:latin typeface="Avenir Next"/>
               </a:rPr>
@@ -4938,7 +4938,7 @@
             <a:r>
               <a:rPr sz="2100" b="1" i="0">
                 <a:solidFill>
-                  <a:srgbClr val="2B2B33"/>
+                  <a:srgbClr val="1E293B"/>
                 </a:solidFill>
                 <a:latin typeface="Avenir Next"/>
               </a:rPr>
@@ -4954,7 +4954,7 @@
             <a:r>
               <a:rPr sz="1800" b="0" i="0">
                 <a:solidFill>
-                  <a:srgbClr val="6B6B76"/>
+                  <a:srgbClr val="5E6B7E"/>
                 </a:solidFill>
                 <a:latin typeface="Avenir Next"/>
               </a:rPr>
@@ -4970,7 +4970,7 @@
             <a:r>
               <a:rPr sz="2100" b="1" i="0">
                 <a:solidFill>
-                  <a:srgbClr val="2B2B33"/>
+                  <a:srgbClr val="1E293B"/>
                 </a:solidFill>
                 <a:latin typeface="Avenir Next"/>
               </a:rPr>
@@ -4986,7 +4986,7 @@
             <a:r>
               <a:rPr sz="1800" b="0" i="0">
                 <a:solidFill>
-                  <a:srgbClr val="6B6B76"/>
+                  <a:srgbClr val="5E6B7E"/>
                 </a:solidFill>
                 <a:latin typeface="Avenir Next"/>
               </a:rPr>
@@ -5009,7 +5009,7 @@
     <p:bg>
       <p:bgPr>
         <a:solidFill>
-          <a:srgbClr val="F4F1EC"/>
+          <a:srgbClr val="FFFFFF"/>
         </a:solidFill>
         <a:effectLst/>
       </p:bgPr>
@@ -5051,7 +5051,7 @@
             <a:r>
               <a:rPr sz="1500" b="1" i="0">
                 <a:solidFill>
-                  <a:srgbClr val="4F7CAC"/>
+                  <a:srgbClr val="2F6FBF"/>
                 </a:solidFill>
                 <a:latin typeface="Avenir Next"/>
               </a:rPr>
@@ -5067,7 +5067,7 @@
             <a:r>
               <a:rPr sz="3800" b="1" i="0">
                 <a:solidFill>
-                  <a:srgbClr val="2B2B33"/>
+                  <a:srgbClr val="1E293B"/>
                 </a:solidFill>
                 <a:latin typeface="Avenir Next"/>
               </a:rPr>
@@ -5091,7 +5091,7 @@
             <a:avLst/>
           </a:prstGeom>
           <a:solidFill>
-            <a:srgbClr val="4F7CAC"/>
+            <a:srgbClr val="5CA3FF"/>
           </a:solidFill>
           <a:ln>
             <a:noFill/>
@@ -5134,7 +5134,7 @@
             <a:avLst/>
           </a:prstGeom>
           <a:solidFill>
-            <a:srgbClr val="FFFFFF"/>
+            <a:srgbClr val="ECF4FF"/>
           </a:solidFill>
           <a:ln>
             <a:noFill/>
@@ -5166,7 +5166,7 @@
             <a:r>
               <a:rPr sz="4000" b="1" i="0">
                 <a:solidFill>
-                  <a:srgbClr val="4F7CAC"/>
+                  <a:srgbClr val="2F6FBF"/>
                 </a:solidFill>
                 <a:latin typeface="Avenir Next"/>
               </a:rPr>
@@ -5182,7 +5182,7 @@
             <a:r>
               <a:rPr sz="1400" b="0" i="0">
                 <a:solidFill>
-                  <a:srgbClr val="6B6B76"/>
+                  <a:srgbClr val="5E6B7E"/>
                 </a:solidFill>
                 <a:latin typeface="Avenir Next"/>
               </a:rPr>
@@ -5206,7 +5206,7 @@
             <a:avLst/>
           </a:prstGeom>
           <a:solidFill>
-            <a:srgbClr val="FFFFFF"/>
+            <a:srgbClr val="ECF4FF"/>
           </a:solidFill>
           <a:ln>
             <a:noFill/>
@@ -5254,7 +5254,7 @@
             <a:r>
               <a:rPr sz="1400" b="0" i="0">
                 <a:solidFill>
-                  <a:srgbClr val="6B6B76"/>
+                  <a:srgbClr val="5E6B7E"/>
                 </a:solidFill>
                 <a:latin typeface="Avenir Next"/>
               </a:rPr>
@@ -5278,7 +5278,7 @@
             <a:avLst/>
           </a:prstGeom>
           <a:solidFill>
-            <a:srgbClr val="FFFFFF"/>
+            <a:srgbClr val="ECF4FF"/>
           </a:solidFill>
           <a:ln>
             <a:noFill/>
@@ -5310,7 +5310,7 @@
             <a:r>
               <a:rPr sz="4000" b="1" i="0">
                 <a:solidFill>
-                  <a:srgbClr val="3A5D84"/>
+                  <a:srgbClr val="2F6FBF"/>
                 </a:solidFill>
                 <a:latin typeface="Avenir Next"/>
               </a:rPr>
@@ -5326,7 +5326,7 @@
             <a:r>
               <a:rPr sz="1400" b="0" i="0">
                 <a:solidFill>
-                  <a:srgbClr val="6B6B76"/>
+                  <a:srgbClr val="5E6B7E"/>
                 </a:solidFill>
                 <a:latin typeface="Avenir Next"/>
               </a:rPr>
@@ -5365,7 +5365,7 @@
             <a:r>
               <a:rPr sz="1900" b="0" i="0">
                 <a:solidFill>
-                  <a:srgbClr val="2B2B33"/>
+                  <a:srgbClr val="1E293B"/>
                 </a:solidFill>
                 <a:latin typeface="Avenir Next"/>
               </a:rPr>
@@ -5381,7 +5381,7 @@
             <a:r>
               <a:rPr sz="1900" b="0" i="0">
                 <a:solidFill>
-                  <a:srgbClr val="6B6B76"/>
+                  <a:srgbClr val="5E6B7E"/>
                 </a:solidFill>
                 <a:latin typeface="Avenir Next"/>
               </a:rPr>
@@ -5404,7 +5404,7 @@
     <p:bg>
       <p:bgPr>
         <a:solidFill>
-          <a:srgbClr val="F4F1EC"/>
+          <a:srgbClr val="FFFFFF"/>
         </a:solidFill>
         <a:effectLst/>
       </p:bgPr>
@@ -5446,7 +5446,7 @@
             <a:r>
               <a:rPr sz="1500" b="1" i="0">
                 <a:solidFill>
-                  <a:srgbClr val="4F7CAC"/>
+                  <a:srgbClr val="2F6FBF"/>
                 </a:solidFill>
                 <a:latin typeface="Avenir Next"/>
               </a:rPr>
@@ -5462,7 +5462,7 @@
             <a:r>
               <a:rPr sz="3800" b="1" i="0">
                 <a:solidFill>
-                  <a:srgbClr val="2B2B33"/>
+                  <a:srgbClr val="1E293B"/>
                 </a:solidFill>
                 <a:latin typeface="Avenir Next"/>
               </a:rPr>
@@ -5486,7 +5486,7 @@
             <a:avLst/>
           </a:prstGeom>
           <a:solidFill>
-            <a:srgbClr val="4F7CAC"/>
+            <a:srgbClr val="5CA3FF"/>
           </a:solidFill>
           <a:ln>
             <a:noFill/>
@@ -5544,7 +5544,7 @@
             <a:r>
               <a:rPr sz="2100" b="1" i="0">
                 <a:solidFill>
-                  <a:srgbClr val="2B2B33"/>
+                  <a:srgbClr val="1E293B"/>
                 </a:solidFill>
                 <a:latin typeface="Avenir Next"/>
               </a:rPr>
@@ -5560,7 +5560,7 @@
             <a:r>
               <a:rPr sz="1800" b="0" i="0">
                 <a:solidFill>
-                  <a:srgbClr val="6B6B76"/>
+                  <a:srgbClr val="5E6B7E"/>
                 </a:solidFill>
                 <a:latin typeface="Avenir Next"/>
               </a:rPr>
@@ -5576,7 +5576,7 @@
             <a:r>
               <a:rPr sz="2100" b="1" i="0">
                 <a:solidFill>
-                  <a:srgbClr val="2B2B33"/>
+                  <a:srgbClr val="1E293B"/>
                 </a:solidFill>
                 <a:latin typeface="Avenir Next"/>
               </a:rPr>
@@ -5592,7 +5592,7 @@
             <a:r>
               <a:rPr sz="1800" b="0" i="0">
                 <a:solidFill>
-                  <a:srgbClr val="6B6B76"/>
+                  <a:srgbClr val="5E6B7E"/>
                 </a:solidFill>
                 <a:latin typeface="Avenir Next"/>
               </a:rPr>
@@ -5608,7 +5608,7 @@
             <a:r>
               <a:rPr sz="2100" b="1" i="0">
                 <a:solidFill>
-                  <a:srgbClr val="2B2B33"/>
+                  <a:srgbClr val="1E293B"/>
                 </a:solidFill>
                 <a:latin typeface="Avenir Next"/>
               </a:rPr>
@@ -5624,7 +5624,7 @@
             <a:r>
               <a:rPr sz="1800" b="0" i="0">
                 <a:solidFill>
-                  <a:srgbClr val="6B6B76"/>
+                  <a:srgbClr val="5E6B7E"/>
                 </a:solidFill>
                 <a:latin typeface="Avenir Next"/>
               </a:rPr>
@@ -5647,7 +5647,7 @@
     <p:bg>
       <p:bgPr>
         <a:solidFill>
-          <a:srgbClr val="F4F1EC"/>
+          <a:srgbClr val="FFFFFF"/>
         </a:solidFill>
         <a:effectLst/>
       </p:bgPr>
@@ -5689,7 +5689,7 @@
             <a:r>
               <a:rPr sz="1500" b="1" i="0">
                 <a:solidFill>
-                  <a:srgbClr val="4F7CAC"/>
+                  <a:srgbClr val="2F6FBF"/>
                 </a:solidFill>
                 <a:latin typeface="Avenir Next"/>
               </a:rPr>
@@ -5705,7 +5705,7 @@
             <a:r>
               <a:rPr sz="3800" b="1" i="0">
                 <a:solidFill>
-                  <a:srgbClr val="2B2B33"/>
+                  <a:srgbClr val="1E293B"/>
                 </a:solidFill>
                 <a:latin typeface="Avenir Next"/>
               </a:rPr>
@@ -5729,7 +5729,7 @@
             <a:avLst/>
           </a:prstGeom>
           <a:solidFill>
-            <a:srgbClr val="4F7CAC"/>
+            <a:srgbClr val="5CA3FF"/>
           </a:solidFill>
           <a:ln>
             <a:noFill/>
@@ -5772,7 +5772,7 @@
             <a:avLst/>
           </a:prstGeom>
           <a:solidFill>
-            <a:srgbClr val="3A5D84"/>
+            <a:srgbClr val="2F6FBF"/>
           </a:solidFill>
           <a:ln>
             <a:noFill/>
@@ -5828,7 +5828,7 @@
             <a:avLst/>
           </a:prstGeom>
           <a:solidFill>
-            <a:srgbClr val="3A5D84"/>
+            <a:srgbClr val="2F6FBF"/>
           </a:solidFill>
           <a:ln>
             <a:noFill/>
@@ -5884,7 +5884,7 @@
             <a:avLst/>
           </a:prstGeom>
           <a:solidFill>
-            <a:srgbClr val="3A5D84"/>
+            <a:srgbClr val="2F6FBF"/>
           </a:solidFill>
           <a:ln>
             <a:noFill/>
@@ -5940,7 +5940,7 @@
             <a:avLst/>
           </a:prstGeom>
           <a:solidFill>
-            <a:srgbClr val="FFFFFF"/>
+            <a:srgbClr val="ECF4FF"/>
           </a:solidFill>
           <a:ln>
             <a:noFill/>
@@ -5972,7 +5972,7 @@
             <a:r>
               <a:rPr sz="1400" b="0" i="0">
                 <a:solidFill>
-                  <a:srgbClr val="2B2B33"/>
+                  <a:srgbClr val="1E293B"/>
                 </a:solidFill>
                 <a:latin typeface="Avenir Next"/>
               </a:rPr>
@@ -5996,7 +5996,7 @@
             <a:avLst/>
           </a:prstGeom>
           <a:solidFill>
-            <a:srgbClr val="FFFFFF"/>
+            <a:srgbClr val="ECF4FF"/>
           </a:solidFill>
           <a:ln>
             <a:noFill/>
@@ -6028,7 +6028,7 @@
             <a:r>
               <a:rPr sz="1400" b="0" i="0">
                 <a:solidFill>
-                  <a:srgbClr val="2B2B33"/>
+                  <a:srgbClr val="1E293B"/>
                 </a:solidFill>
                 <a:latin typeface="Avenir Next"/>
               </a:rPr>
@@ -6052,7 +6052,7 @@
             <a:avLst/>
           </a:prstGeom>
           <a:solidFill>
-            <a:srgbClr val="FFFFFF"/>
+            <a:srgbClr val="ECF4FF"/>
           </a:solidFill>
           <a:ln>
             <a:noFill/>
@@ -6084,7 +6084,7 @@
             <a:r>
               <a:rPr sz="1400" b="0" i="0">
                 <a:solidFill>
-                  <a:srgbClr val="2B2B33"/>
+                  <a:srgbClr val="1E293B"/>
                 </a:solidFill>
                 <a:latin typeface="Avenir Next"/>
               </a:rPr>
@@ -6108,7 +6108,7 @@
             <a:avLst/>
           </a:prstGeom>
           <a:solidFill>
-            <a:srgbClr val="FFFFFF"/>
+            <a:srgbClr val="ECF4FF"/>
           </a:solidFill>
           <a:ln>
             <a:noFill/>
@@ -6140,7 +6140,7 @@
             <a:r>
               <a:rPr sz="1400" b="0" i="0">
                 <a:solidFill>
-                  <a:srgbClr val="2B2B33"/>
+                  <a:srgbClr val="1E293B"/>
                 </a:solidFill>
                 <a:latin typeface="Avenir Next"/>
               </a:rPr>
@@ -6164,7 +6164,7 @@
             <a:avLst/>
           </a:prstGeom>
           <a:solidFill>
-            <a:srgbClr val="FFFFFF"/>
+            <a:srgbClr val="ECF4FF"/>
           </a:solidFill>
           <a:ln>
             <a:noFill/>
@@ -6196,7 +6196,7 @@
             <a:r>
               <a:rPr sz="1400" b="0" i="0">
                 <a:solidFill>
-                  <a:srgbClr val="2B2B33"/>
+                  <a:srgbClr val="1E293B"/>
                 </a:solidFill>
                 <a:latin typeface="Avenir Next"/>
               </a:rPr>
@@ -6220,7 +6220,7 @@
             <a:avLst/>
           </a:prstGeom>
           <a:solidFill>
-            <a:srgbClr val="FFFFFF"/>
+            <a:srgbClr val="ECF4FF"/>
           </a:solidFill>
           <a:ln>
             <a:noFill/>
@@ -6252,7 +6252,7 @@
             <a:r>
               <a:rPr sz="1400" b="0" i="0">
                 <a:solidFill>
-                  <a:srgbClr val="2B2B33"/>
+                  <a:srgbClr val="1E293B"/>
                 </a:solidFill>
                 <a:latin typeface="Avenir Next"/>
               </a:rPr>
@@ -6276,7 +6276,7 @@
             <a:avLst/>
           </a:prstGeom>
           <a:solidFill>
-            <a:srgbClr val="FFFFFF"/>
+            <a:srgbClr val="ECF4FF"/>
           </a:solidFill>
           <a:ln>
             <a:noFill/>
@@ -6308,7 +6308,7 @@
             <a:r>
               <a:rPr sz="1400" b="0" i="0">
                 <a:solidFill>
-                  <a:srgbClr val="2B2B33"/>
+                  <a:srgbClr val="1E293B"/>
                 </a:solidFill>
                 <a:latin typeface="Avenir Next"/>
               </a:rPr>
@@ -6332,7 +6332,7 @@
             <a:avLst/>
           </a:prstGeom>
           <a:solidFill>
-            <a:srgbClr val="FFFFFF"/>
+            <a:srgbClr val="ECF4FF"/>
           </a:solidFill>
           <a:ln>
             <a:noFill/>
@@ -6364,7 +6364,7 @@
             <a:r>
               <a:rPr sz="1400" b="0" i="0">
                 <a:solidFill>
-                  <a:srgbClr val="2B2B33"/>
+                  <a:srgbClr val="1E293B"/>
                 </a:solidFill>
                 <a:latin typeface="Avenir Next"/>
               </a:rPr>
@@ -6388,7 +6388,7 @@
             <a:avLst/>
           </a:prstGeom>
           <a:solidFill>
-            <a:srgbClr val="FFFFFF"/>
+            <a:srgbClr val="ECF4FF"/>
           </a:solidFill>
           <a:ln>
             <a:noFill/>
@@ -6420,7 +6420,7 @@
             <a:r>
               <a:rPr sz="1400" b="0" i="0">
                 <a:solidFill>
-                  <a:srgbClr val="2B2B33"/>
+                  <a:srgbClr val="1E293B"/>
                 </a:solidFill>
                 <a:latin typeface="Avenir Next"/>
               </a:rPr>
@@ -6627,7 +6627,7 @@
             <a:r>
               <a:rPr sz="1900" b="1" i="1">
                 <a:solidFill>
-                  <a:srgbClr val="3A5D84"/>
+                  <a:srgbClr val="2F6FBF"/>
                 </a:solidFill>
                 <a:latin typeface="Avenir Next"/>
               </a:rPr>
@@ -6650,7 +6650,7 @@
     <p:bg>
       <p:bgPr>
         <a:solidFill>
-          <a:srgbClr val="F4F1EC"/>
+          <a:srgbClr val="FFFFFF"/>
         </a:solidFill>
         <a:effectLst/>
       </p:bgPr>
@@ -6692,7 +6692,7 @@
             <a:r>
               <a:rPr sz="1500" b="1" i="0">
                 <a:solidFill>
-                  <a:srgbClr val="4F7CAC"/>
+                  <a:srgbClr val="2F6FBF"/>
                 </a:solidFill>
                 <a:latin typeface="Avenir Next"/>
               </a:rPr>
@@ -6708,7 +6708,7 @@
             <a:r>
               <a:rPr sz="3800" b="1" i="0">
                 <a:solidFill>
-                  <a:srgbClr val="2B2B33"/>
+                  <a:srgbClr val="1E293B"/>
                 </a:solidFill>
                 <a:latin typeface="Avenir Next"/>
               </a:rPr>
@@ -6732,7 +6732,7 @@
             <a:avLst/>
           </a:prstGeom>
           <a:solidFill>
-            <a:srgbClr val="4F7CAC"/>
+            <a:srgbClr val="5CA3FF"/>
           </a:solidFill>
           <a:ln>
             <a:noFill/>
@@ -6790,7 +6790,7 @@
             <a:r>
               <a:rPr sz="2000" b="1" i="0">
                 <a:solidFill>
-                  <a:srgbClr val="2B2B33"/>
+                  <a:srgbClr val="1E293B"/>
                 </a:solidFill>
                 <a:latin typeface="Avenir Next"/>
               </a:rPr>
@@ -6806,7 +6806,7 @@
             <a:r>
               <a:rPr sz="1700" b="0" i="0">
                 <a:solidFill>
-                  <a:srgbClr val="6B6B76"/>
+                  <a:srgbClr val="5E6B7E"/>
                 </a:solidFill>
                 <a:latin typeface="Avenir Next"/>
               </a:rPr>
@@ -6822,7 +6822,7 @@
             <a:r>
               <a:rPr sz="2000" b="1" i="0">
                 <a:solidFill>
-                  <a:srgbClr val="2B2B33"/>
+                  <a:srgbClr val="1E293B"/>
                 </a:solidFill>
                 <a:latin typeface="Avenir Next"/>
               </a:rPr>
@@ -6838,7 +6838,7 @@
             <a:r>
               <a:rPr sz="1700" b="0" i="0">
                 <a:solidFill>
-                  <a:srgbClr val="6B6B76"/>
+                  <a:srgbClr val="5E6B7E"/>
                 </a:solidFill>
                 <a:latin typeface="Avenir Next"/>
               </a:rPr>
@@ -6854,7 +6854,7 @@
             <a:r>
               <a:rPr sz="2000" b="1" i="0">
                 <a:solidFill>
-                  <a:srgbClr val="2B2B33"/>
+                  <a:srgbClr val="1E293B"/>
                 </a:solidFill>
                 <a:latin typeface="Avenir Next"/>
               </a:rPr>
@@ -6870,7 +6870,7 @@
             <a:r>
               <a:rPr sz="1700" b="0" i="0">
                 <a:solidFill>
-                  <a:srgbClr val="6B6B76"/>
+                  <a:srgbClr val="5E6B7E"/>
                 </a:solidFill>
                 <a:latin typeface="Avenir Next"/>
               </a:rPr>
@@ -6886,7 +6886,7 @@
             <a:r>
               <a:rPr sz="2000" b="1" i="0">
                 <a:solidFill>
-                  <a:srgbClr val="2B2B33"/>
+                  <a:srgbClr val="1E293B"/>
                 </a:solidFill>
                 <a:latin typeface="Avenir Next"/>
               </a:rPr>
@@ -6902,7 +6902,7 @@
             <a:r>
               <a:rPr sz="1700" b="0" i="0">
                 <a:solidFill>
-                  <a:srgbClr val="6B6B76"/>
+                  <a:srgbClr val="5E6B7E"/>
                 </a:solidFill>
                 <a:latin typeface="Avenir Next"/>
               </a:rPr>

</xml_diff>

<commit_message>
Add AI-generated campaign hero image; use it on the deck title slide
Generated with Higgsfield Soul V2 (0.24 credits total for two takes).
Title slide is now the full-bleed campaign photo with a white title
block and brand chip placed over the model's garbled text areas.

Co-Authored-By: Claude Fable 5 <noreply@anthropic.com>
</commit_message>
<xml_diff>
--- a/pitch/DigitalTwin-Pitch-Deck.pptx
+++ b/pitch/DigitalTwin-Pitch-Deck.pptx
@@ -3094,7 +3094,7 @@
     <p:bg>
       <p:bgPr>
         <a:solidFill>
-          <a:srgbClr val="5CA3FF"/>
+          <a:srgbClr val="FFFFFF"/>
         </a:solidFill>
         <a:effectLst/>
       </p:bgPr>
@@ -3106,89 +3106,170 @@
         <p:nvPr/>
       </p:nvGrpSpPr>
       <p:grpSpPr/>
-      <p:sp>
-        <p:nvSpPr>
-          <p:cNvPr id="2" name="TextBox 1"/>
-          <p:cNvSpPr txBox="1"/>
+      <p:pic>
+        <p:nvPicPr>
+          <p:cNvPr id="2" name="Picture 1" descr="digitaltwin-ad-clean.png"/>
+          <p:cNvPicPr>
+            <a:picLocks noChangeAspect="1"/>
+          </p:cNvPicPr>
           <p:nvPr/>
-        </p:nvSpPr>
-        <p:spPr>
-          <a:xfrm>
-            <a:off x="1371600" y="2011680"/>
-            <a:ext cx="9418320" cy="2926080"/>
+        </p:nvPicPr>
+        <p:blipFill>
+          <a:blip r:embed="rId2"/>
+          <a:stretch>
+            <a:fillRect/>
+          </a:stretch>
+        </p:blipFill>
+        <p:spPr>
+          <a:xfrm>
+            <a:off x="0" y="0"/>
+            <a:ext cx="12191695" cy="6858000"/>
           </a:xfrm>
           <a:prstGeom prst="rect">
             <a:avLst/>
           </a:prstGeom>
-          <a:noFill/>
-        </p:spPr>
-        <p:txBody>
-          <a:bodyPr wrap="square">
-            <a:spAutoFit/>
-          </a:bodyPr>
+        </p:spPr>
+      </p:pic>
+      <p:sp>
+        <p:nvSpPr>
+          <p:cNvPr id="3" name="Rounded Rectangle 2"/>
+          <p:cNvSpPr/>
+          <p:nvPr/>
+        </p:nvSpPr>
+        <p:spPr>
+          <a:xfrm>
+            <a:off x="320040" y="4892040"/>
+            <a:ext cx="6035040" cy="1691640"/>
+          </a:xfrm>
+          <a:prstGeom prst="roundRect">
+            <a:avLst/>
+          </a:prstGeom>
+          <a:solidFill>
+            <a:srgbClr val="FFFFFF"/>
+          </a:solidFill>
+          <a:ln>
+            <a:noFill/>
+          </a:ln>
+        </p:spPr>
+        <p:style>
+          <a:lnRef idx="1">
+            <a:schemeClr val="accent1"/>
+          </a:lnRef>
+          <a:fillRef idx="3">
+            <a:schemeClr val="accent1"/>
+          </a:fillRef>
+          <a:effectRef idx="2">
+            <a:schemeClr val="accent1"/>
+          </a:effectRef>
+          <a:fontRef idx="minor">
+            <a:schemeClr val="lt1"/>
+          </a:fontRef>
+        </p:style>
+        <p:txBody>
+          <a:bodyPr rtlCol="0" anchor="ctr" lIns="274320" tIns="146304" rIns="274320"/>
+          <a:lstStyle/>
+          <a:p>
+            <a:pPr algn="l">
+              <a:spcAft>
+                <a:spcPts val="200"/>
+              </a:spcAft>
+            </a:pPr>
+            <a:r>
+              <a:rPr sz="4000" b="1" i="0">
+                <a:solidFill>
+                  <a:srgbClr val="2F6FBF"/>
+                </a:solidFill>
+                <a:latin typeface="Avenir Next"/>
+              </a:rPr>
+              <a:t>DigitalTwin</a:t>
+            </a:r>
+          </a:p>
+          <a:p>
+            <a:pPr algn="l">
+              <a:spcAft>
+                <a:spcPts val="600"/>
+              </a:spcAft>
+            </a:pPr>
+            <a:r>
+              <a:rPr sz="1600" b="0" i="0">
+                <a:solidFill>
+                  <a:srgbClr val="5E6B7E"/>
+                </a:solidFill>
+                <a:latin typeface="Avenir Next"/>
+              </a:rPr>
+              <a:t>An AI daily companion for Mom. Real-time peace of mind for you.</a:t>
+            </a:r>
+          </a:p>
+          <a:p>
+            <a:pPr algn="l">
+              <a:spcAft>
+                <a:spcPts val="0"/>
+              </a:spcAft>
+            </a:pPr>
+            <a:r>
+              <a:rPr sz="1100" b="0" i="0">
+                <a:solidFill>
+                  <a:srgbClr val="5E6B7E"/>
+                </a:solidFill>
+                <a:latin typeface="Avenir Next"/>
+              </a:rPr>
+              <a:t>Kaleb Rodriguez · Saanvi Rout · Ishaan Varma Kammella · Hemaprabaa Rajakumar · Hur Rauf Sirin</a:t>
+            </a:r>
+          </a:p>
+        </p:txBody>
+      </p:sp>
+      <p:sp>
+        <p:nvSpPr>
+          <p:cNvPr id="4" name="Rounded Rectangle 3"/>
+          <p:cNvSpPr/>
+          <p:nvPr/>
+        </p:nvSpPr>
+        <p:spPr>
+          <a:xfrm>
+            <a:off x="9829800" y="6144768"/>
+            <a:ext cx="2057400" cy="457200"/>
+          </a:xfrm>
+          <a:prstGeom prst="roundRect">
+            <a:avLst/>
+          </a:prstGeom>
+          <a:solidFill>
+            <a:srgbClr val="FFFFFF"/>
+          </a:solidFill>
+          <a:ln>
+            <a:noFill/>
+          </a:ln>
+        </p:spPr>
+        <p:style>
+          <a:lnRef idx="1">
+            <a:schemeClr val="accent1"/>
+          </a:lnRef>
+          <a:fillRef idx="3">
+            <a:schemeClr val="accent1"/>
+          </a:fillRef>
+          <a:effectRef idx="2">
+            <a:schemeClr val="accent1"/>
+          </a:effectRef>
+          <a:fontRef idx="minor">
+            <a:schemeClr val="lt1"/>
+          </a:fontRef>
+        </p:style>
+        <p:txBody>
+          <a:bodyPr rtlCol="0" anchor="ctr"/>
           <a:lstStyle/>
           <a:p>
             <a:pPr algn="ctr">
               <a:spcAft>
-                <a:spcPts val="1000"/>
-              </a:spcAft>
-            </a:pPr>
-            <a:r>
-              <a:rPr sz="6600" b="1" i="0">
-                <a:solidFill>
-                  <a:srgbClr val="FFFFFF"/>
-                </a:solidFill>
-                <a:latin typeface="Avenir Next"/>
-              </a:rPr>
-              <a:t>DigitalTwin</a:t>
-            </a:r>
-          </a:p>
-          <a:p>
-            <a:pPr algn="ctr">
-              <a:spcAft>
-                <a:spcPts val="200"/>
-              </a:spcAft>
-            </a:pPr>
-            <a:r>
-              <a:rPr sz="2600" b="0" i="0">
-                <a:solidFill>
-                  <a:srgbClr val="ECF4FF"/>
-                </a:solidFill>
-                <a:latin typeface="Avenir Next"/>
-              </a:rPr>
-              <a:t>An AI daily companion for Mom.</a:t>
-            </a:r>
-          </a:p>
-          <a:p>
-            <a:pPr algn="ctr">
-              <a:spcAft>
-                <a:spcPts val="2400"/>
-              </a:spcAft>
-            </a:pPr>
-            <a:r>
-              <a:rPr sz="2600" b="1" i="0">
-                <a:solidFill>
-                  <a:srgbClr val="FFFFFF"/>
-                </a:solidFill>
-                <a:latin typeface="Avenir Next"/>
-              </a:rPr>
-              <a:t>Real-time peace of mind for you.</a:t>
-            </a:r>
-          </a:p>
-          <a:p>
-            <a:pPr algn="ctr">
-              <a:spcAft>
                 <a:spcPts val="0"/>
               </a:spcAft>
             </a:pPr>
             <a:r>
-              <a:rPr sz="1400" b="0" i="0">
-                <a:solidFill>
-                  <a:srgbClr val="ECF4FF"/>
-                </a:solidFill>
-                <a:latin typeface="Avenir Next"/>
-              </a:rPr>
-              <a:t>Kaleb Rodriguez  •  Saanvi Rout  •  Ishaan Varma Kammella  •  Hemaprabaa Rajakumar  •  Hur Rauf Sirin</a:t>
+              <a:rPr sz="1600" b="1" i="0">
+                <a:solidFill>
+                  <a:srgbClr val="5CA3FF"/>
+                </a:solidFill>
+                <a:latin typeface="Avenir Next"/>
+              </a:rPr>
+              <a:t>digitaltwin</a:t>
             </a:r>
           </a:p>
         </p:txBody>

</xml_diff>